<commit_message>
Re-run the official evaluation with Gemini (default provider)
- Pre-warmed plans and benchmark on gemini-3.1-flash-lite: every cold request served by the primary model
- results.jsonl, metrics.md, stress report, README, FINAL_REVIEW, traceability and AI disclosure updated
- Earlier Groq run archived in artifacts/reports/official_groq/
- Submission deck and disclosure form regenerated with the Gemini numbers and a new demo screenshot
</commit_message>
<xml_diff>
--- a/docs/CollegeName_TeamName_Submission.pptx
+++ b/docs/CollegeName_TeamName_Submission.pptx
@@ -16326,7 +16326,7 @@
                   <a:srgbClr val="63637E"/>
                 </a:solidFill>
               </a:rPr>
-              <a:t>[auto] Enable Touch Sensitivity → placeholder link (voiceassist://dummy_positive)</a:t>
+              <a:t>[auto] Configure Touch Sensitivity</a:t>
             </a:r>
           </a:p>
           <a:p>
@@ -16371,7 +16371,7 @@
                   <a:srgbClr val="63637E"/>
                 </a:solidFill>
               </a:rPr>
-              <a:t>[manual] Check Charger</a:t>
+              <a:t>[critical] Restart Device</a:t>
             </a:r>
           </a:p>
         </p:txBody>
@@ -16675,7 +16675,7 @@
                             <a:srgbClr val="14142B"/>
                           </a:solidFill>
                         </a:rPr>
-                        <a:t>Groq openai/gpt-oss-120b (extraction), openai/gpt-oss-20b (variations); Gemini supported</a:t>
+                        <a:t>Google Gemini gemini-3.1-flash-lite (extraction and variations; fail-over gemini-3.5-flash-lite → gemini-3.6-flash); Groq gpt-oss also supported</a:t>
                       </a:r>
                     </a:p>
                   </a:txBody>
@@ -17293,7 +17293,7 @@
                   <a:srgbClr val="14142B"/>
                 </a:solidFill>
               </a:rPr>
-              <a:t> cold path ≈ $0.00037 per query (2.00 model calls, 2117 input / 671 output tokens); cache hits cost $0.</a:t>
+              <a:t> cold path ≈ $0.00118 per query (1.46 model calls, 1607 input / 516 output tokens); cache hits cost $0.</a:t>
             </a:r>
           </a:p>
           <a:p>
@@ -17793,7 +17793,7 @@
                             <a:srgbClr val="15803D"/>
                           </a:solidFill>
                         </a:rPr>
-                        <a:t>100% (83/83)</a:t>
+                        <a:t>100% (85/85)</a:t>
                       </a:r>
                     </a:p>
                   </a:txBody>
@@ -17858,7 +17858,7 @@
                             <a:srgbClr val="B45309"/>
                           </a:solidFill>
                         </a:rPr>
-                        <a:t>24.5%</a:t>
+                        <a:t>31.5%</a:t>
                       </a:r>
                     </a:p>
                   </a:txBody>
@@ -17988,7 +17988,7 @@
                             <a:srgbClr val="15803D"/>
                           </a:solidFill>
                         </a:rPr>
-                        <a:t>30 ms</a:t>
+                        <a:t>38 ms</a:t>
                       </a:r>
                     </a:p>
                   </a:txBody>
@@ -18053,7 +18053,7 @@
                             <a:srgbClr val="15803D"/>
                           </a:solidFill>
                         </a:rPr>
-                        <a:t>2.17 s</a:t>
+                        <a:t>2.58 s</a:t>
                       </a:r>
                     </a:p>
                   </a:txBody>
@@ -18118,7 +18118,7 @@
                             <a:srgbClr val="15803D"/>
                           </a:solidFill>
                         </a:rPr>
-                        <a:t>83.8% (67/80)</a:t>
+                        <a:t>81.2% (65/80)</a:t>
                       </a:r>
                     </a:p>
                   </a:txBody>
@@ -18183,7 +18183,7 @@
                             <a:srgbClr val="B45309"/>
                           </a:solidFill>
                         </a:rPr>
-                        <a:t>4/80</a:t>
+                        <a:t>1/80</a:t>
                       </a:r>
                     </a:p>
                   </a:txBody>
@@ -18386,7 +18386,7 @@
                   <a:srgbClr val="14142B"/>
                 </a:solidFill>
               </a:rPr>
-              <a:t>• Free-tier daily quota ran out in the final run: 18/26 cold requests used the fail-over model.</a:t>
+              <a:t>• One multi-intent edge case (E04) returned no_match instead of a plan.</a:t>
             </a:r>
           </a:p>
           <a:p>

</xml_diff>

<commit_message>
Add team details (ResolveAI, VITV) to the deck, disclosure form and README
</commit_message>
<xml_diff>
--- a/docs/CollegeName_TeamName_Submission.pptx
+++ b/docs/CollegeName_TeamName_Submission.pptx
@@ -13150,10 +13150,10 @@
             <a:r>
               <a:rPr sz="1600" b="0">
                 <a:solidFill>
-                  <a:srgbClr val="63637E"/>
+                  <a:srgbClr val="14142B"/>
                 </a:solidFill>
               </a:rPr>
-              <a:t> Theme 2: Troubleshooting  [TO FILL: Theme ID]</a:t>
+              <a:t> Theme 2: Troubleshooting</a:t>
             </a:r>
             <a:endParaRPr/>
           </a:p>
@@ -13187,10 +13187,10 @@
             <a:r>
               <a:rPr sz="1600" b="0">
                 <a:solidFill>
-                  <a:srgbClr val="63637E"/>
+                  <a:srgbClr val="14142B"/>
                 </a:solidFill>
               </a:rPr>
-              <a:t> [TO FILL]</a:t>
+              <a:t> ResolveAI</a:t>
             </a:r>
             <a:endParaRPr/>
           </a:p>
@@ -13224,10 +13224,10 @@
             <a:r>
               <a:rPr sz="1600" b="0">
                 <a:solidFill>
-                  <a:srgbClr val="63637E"/>
+                  <a:srgbClr val="14142B"/>
                 </a:solidFill>
               </a:rPr>
-              <a:t> [TO FILL]</a:t>
+              <a:t> VITV</a:t>
             </a:r>
             <a:endParaRPr/>
           </a:p>
@@ -13261,10 +13261,10 @@
             <a:r>
               <a:rPr sz="1600" b="0">
                 <a:solidFill>
-                  <a:srgbClr val="63637E"/>
+                  <a:srgbClr val="14142B"/>
                 </a:solidFill>
               </a:rPr>
-              <a:t> [TO FILL]</a:t>
+              <a:t> Shashi Bhushan – shashibhushan.vijay2022@vitstudent.ac.in</a:t>
             </a:r>
             <a:endParaRPr/>
           </a:p>
@@ -13298,10 +13298,10 @@
             <a:r>
               <a:rPr sz="1600" b="0">
                 <a:solidFill>
-                  <a:srgbClr val="63637E"/>
+                  <a:srgbClr val="14142B"/>
                 </a:solidFill>
               </a:rPr>
-              <a:t> [TO FILL]</a:t>
+              <a:t> Astha Doshi – astha.doshi2023@vitstudent.ac.in</a:t>
             </a:r>
             <a:endParaRPr/>
           </a:p>
@@ -13335,10 +13335,10 @@
             <a:r>
               <a:rPr sz="1600" b="0">
                 <a:solidFill>
-                  <a:srgbClr val="63637E"/>
+                  <a:srgbClr val="14142B"/>
                 </a:solidFill>
               </a:rPr>
-              <a:t> [TO FILL]</a:t>
+              <a:t> Himangi Khanduri – himangi.khanduri2023@vitstudent.ac.in</a:t>
             </a:r>
             <a:endParaRPr/>
           </a:p>
@@ -13367,49 +13367,12 @@
                 <a:cs typeface="Calibri"/>
                 <a:sym typeface="Calibri"/>
               </a:rPr>
-              <a:t>Member Name &amp; Email 4-</a:t>
+              <a:t>Submission Github link - </a:t>
             </a:r>
             <a:r>
               <a:rPr sz="1600" b="0">
                 <a:solidFill>
-                  <a:srgbClr val="63637E"/>
-                </a:solidFill>
-              </a:rPr>
-              <a:t> [TO FILL]</a:t>
-            </a:r>
-            <a:endParaRPr/>
-          </a:p>
-          <a:p>
-            <a:pPr indent="-177800" lvl="0" marL="177800" marR="0" rtl="0" algn="l">
-              <a:spcBef>
-                <a:spcPts val="500"/>
-              </a:spcBef>
-              <a:spcAft>
-                <a:spcPts val="0"/>
-              </a:spcAft>
-              <a:buClr>
-                <a:srgbClr val="63637E"/>
-              </a:buClr>
-              <a:buSzPts val="1600"/>
-              <a:buFont typeface="Calibri"/>
-              <a:buChar char="•"/>
-            </a:pPr>
-            <a:r>
-              <a:rPr b="0" i="0" lang="en-US" sz="1600" u="none" cap="none" strike="noStrike">
-                <a:solidFill>
-                  <a:srgbClr val="63637E"/>
-                </a:solidFill>
-                <a:latin typeface="Calibri"/>
-                <a:ea typeface="Calibri"/>
-                <a:cs typeface="Calibri"/>
-                <a:sym typeface="Calibri"/>
-              </a:rPr>
-              <a:t>Submission Github link - </a:t>
-            </a:r>
-            <a:r>
-              <a:rPr sz="1600" b="1">
-                <a:solidFill>
-                  <a:srgbClr val="6D28D9"/>
+                  <a:srgbClr val="14142B"/>
                 </a:solidFill>
               </a:rPr>
               <a:t> https://github.com/shashi-bhushan-27/samsungPrism  (tag PRISM_GENAI_HACKATHON_Y2026)</a:t>

</xml_diff>